<commit_message>
Presentation route: full speaker notes on all 15 slides; README notes PowerPoint choice
</commit_message>
<xml_diff>
--- a/ITAI2373-NewsBot-Final/reports/FP_Presentation_TrilokKalani_SOLO_ITAI2373.pptx
+++ b/ITAI2373-NewsBot-Final/reports/FP_Presentation_TrilokKalani_SOLO_ITAI2373.pptx
@@ -515,10 +515,8 @@
           <a:lstStyle/>
           <a:p>
             <a:r>
-              <a:rPr lang="en-US" dirty="0"/>
-              <a:t>Hi, I am Trilok Kalani, this is my ITAI 2373 final project, NewsBot Intelligence System 2.0, done as an individual project. The midterm was a single-notebook pipeline; the final is a modular system with four advanced modules plus a web app.</a:t>
-            </a:r>
-            <a:endParaRPr lang="en-US" dirty="0"/>
+              <a:t>Hi, I am Trilok Kalani, and this is my ITAI 2373 final project, NewsBot Intelligence System 2.0. I completed it as an individual (SOLO) project. For the midterm I built an end-to-end news analysis pipeline in a single notebook. For the final I rebuilt it into a modular, production-style system and added four advanced modules plus a web front end that is live online.</a:t>
+            </a:r>
           </a:p>
         </p:txBody>
       </p:sp>
@@ -603,10 +601,8 @@
           <a:lstStyle/>
           <a:p>
             <a:r>
-              <a:rPr lang="en-US" dirty="0"/>
-              <a:t>Four fresh June 2026 articles, one per beat, all classified correctly with high confidence, each with sentiment and emotion. Short off-topic input returns uncertain. These come from the real pipeline.</a:t>
-            </a:r>
-            <a:endParaRPr lang="en-US" dirty="0"/>
+              <a:t>On four fresh June 2026 articles, one per beat, the system classifies all of them correctly with high confidence: technology as tech, the markets story as business, the World Cup story as sport at 96 percent, and the UK politics story as politics at 97 percent, each with its sentiment and emotion. Short off-topic input returns 'uncertain' rather than a forced label. These are the model's real outputs.</a:t>
+            </a:r>
           </a:p>
         </p:txBody>
       </p:sp>
@@ -691,10 +687,8 @@
           <a:lstStyle/>
           <a:p>
             <a:r>
-              <a:rPr lang="en-US" dirty="0"/>
-              <a:t>The LDA topics, learned with no labels, line up cleanly with the five categories. That is a good sign the unsupervised side is finding real structure, not noise.</a:t>
-            </a:r>
-            <a:endParaRPr lang="en-US" dirty="0"/>
+              <a:t>These are the topics the model discovered with LDA, learned with no labels at all. After removing English stopwords they line up cleanly with the five news beats: sport, entertainment, tech, business, and politics. That is a good sign the unsupervised side is finding real structure rather than noise.</a:t>
+            </a:r>
           </a:p>
         </p:txBody>
       </p:sp>
@@ -779,10 +773,8 @@
           <a:lstStyle/>
           <a:p>
             <a:r>
-              <a:rPr lang="en-US" dirty="0"/>
-              <a:t>About 97.5 percent test accuracy, Linear SVM best, all four models above 94 percent. The only real confusions are a few politics and business articles that share vocabulary.</a:t>
-            </a:r>
-            <a:endParaRPr lang="en-US" dirty="0"/>
+              <a:t>The classification foundation reaches about 97.5 percent test accuracy on the five BBC categories, with Linear SVM best and all four models above 94 percent. The only real confusions are a few politics and business articles that share vocabulary such as tax and economy.</a:t>
+            </a:r>
           </a:p>
         </p:txBody>
       </p:sp>
@@ -867,10 +859,8 @@
           <a:lstStyle/>
           <a:p>
             <a:r>
-              <a:rPr lang="en-US" dirty="0"/>
-              <a:t>This maps onto media intelligence. Flag mentions, warn on negative tone, build a searchable entity index, and let people ask questions instead of learning a query language. Multilingual support widens the reach.</a:t>
-            </a:r>
-            <a:endParaRPr lang="en-US" dirty="0"/>
+              <a:t>In the real world this maps onto media intelligence. A communications team can flag every article that mentions them and get warned when the tone turns negative. Investor relations can track how a company or sector is covered. Media teams can cluster a day's coverage into topics, and the multilingual layer extends all of this to non-English sources.</a:t>
+            </a:r>
           </a:p>
         </p:txBody>
       </p:sp>
@@ -955,10 +945,8 @@
           <a:lstStyle/>
           <a:p>
             <a:r>
-              <a:rPr lang="en-US" dirty="0"/>
-              <a:t>I tried to be honest. The model is trained on older news, the lexicon sentiment misreads financial language, NER makes occasional errors, and translation needs a network. Knowing the limits is what makes a tool trustworthy.</a:t>
-            </a:r>
-            <a:endParaRPr lang="en-US" dirty="0"/>
+              <a:t>I tried to be honest about the limits. The model is trained on 2004 to 2005 BBC news, so it is weaker on messy present-day text. The lexicon sentiment misreads financial framing and can score a profit warning as positive. The small spaCy model makes occasional entity errors, and translation needs a network connection. Stating the limits plainly is the point, because trustworthy tooling depends on knowing where it is wrong.</a:t>
+            </a:r>
           </a:p>
         </p:txBody>
       </p:sp>
@@ -1043,10 +1031,8 @@
           <a:lstStyle/>
           <a:p>
             <a:r>
-              <a:rPr lang="en-US" dirty="0"/>
-              <a:t>Future work: swap in FinBERT, fine-tune NER on recent news, add topic modeling over time, deploy to a public URL with batch upload, and explore bias detection and fact checking. Thank you for watching.</a:t>
-            </a:r>
-            <a:endParaRPr lang="en-US" dirty="0"/>
+              <a:t>If I keep building on this, the first change is replacing the lexicon sentiment with a finance-tuned model like FinBERT. After that I would fine-tune the entity recognizer on recent news, add topic modeling over time, and expand the deployment with batch upload and caching. Everything is on my GitHub with a live demo link in the README. Thank you.</a:t>
+            </a:r>
           </a:p>
         </p:txBody>
       </p:sp>
@@ -1131,10 +1117,8 @@
           <a:lstStyle/>
           <a:p>
             <a:r>
-              <a:rPr lang="en-US" dirty="0"/>
-              <a:t>Teams need fast, contextual awareness of coverage. Keyword alerts miss tone and context. NewsBot returns category, sentiment, entities, summary, topics, semantic search, and a conversational interface, in a browser.</a:t>
-            </a:r>
-            <a:endParaRPr lang="en-US" dirty="0"/>
+              <a:t>Organizations are buried in news and need to know, within minutes, what is being said about them, whether the tone is turning, and who is being named. Reading feeds by hand does not scale, and keyword alerts miss context. NewsBot turns raw article text into structured intelligence: category with confidence, sentiment and emotion, named entities, a summary, discovered topics, semantic search, and a conversational interface, all reachable from a browser.</a:t>
+            </a:r>
           </a:p>
         </p:txBody>
       </p:sp>
@@ -1219,10 +1203,8 @@
           <a:lstStyle/>
           <a:p>
             <a:r>
-              <a:rPr lang="en-US" dirty="0"/>
-              <a:t>The biggest change is structure. The midterm was one notebook; the final is a package where each capability is its own testable class. That refactor is what let me wire four new modules together instead of copying code.</a:t>
-            </a:r>
-            <a:endParaRPr lang="en-US" dirty="0"/>
+              <a:t>The biggest change from the midterm is structure. The midterm was one long notebook. The final is a Python package where every capability is its own small class under the source folder, so I can test each part alone and reuse it from the notebooks, the tests, and the web app. That refactor is what made the four new modules possible.</a:t>
+            </a:r>
           </a:p>
         </p:txBody>
       </p:sp>
@@ -1307,10 +1289,8 @@
           <a:lstStyle/>
           <a:p>
             <a:r>
-              <a:rPr lang="en-US" dirty="0"/>
-              <a:t>Raw text enters a thin facade that does classification, sentiment, and entities. The four modules sit on top, and the Flask app is a presentation layer over the same components. Design rule: parse and vectorize once, reuse everywhere.</a:t>
-            </a:r>
-            <a:endParaRPr lang="en-US" dirty="0"/>
+              <a:t>Raw article text enters a thin facade called NewsBot that handles classification, sentiment, and entities. The four modules sit on top, and the Flask web app is a presentation layer over the same components. The design rule is parse and vectorize once, then reuse. The classifier owns the TF-IDF vectorizer, while search and topic modeling keep their own, tuned for recall.</a:t>
+            </a:r>
           </a:p>
         </p:txBody>
       </p:sp>
@@ -1395,10 +1375,8 @@
           <a:lstStyle/>
           <a:p>
             <a:r>
-              <a:rPr lang="en-US" dirty="0"/>
-              <a:t>Module A. Classification reports confidence and recognized words and returns uncertain when it should. Plus sentiment with emotion, domain-aware NER, and topic modeling with both LDA and NMF.</a:t>
-            </a:r>
-            <a:endParaRPr lang="en-US" dirty="0"/>
+              <a:t>Module A is advanced content analysis. Classification returns the category, a confidence score, the runner-up, and how many words it recognized, and it returns 'uncertain' on empty or out-of-scope input instead of guessing. It also does sentiment with an emotion label, named entity recognition with a domain rule layer, and topic modeling with both LDA and NMF.</a:t>
+            </a:r>
           </a:p>
         </p:txBody>
       </p:sp>
@@ -1483,10 +1461,8 @@
           <a:lstStyle/>
           <a:p>
             <a:r>
-              <a:rPr lang="en-US" dirty="0"/>
-              <a:t>Module B. Extractive summaries by default with an optional transformer path. Semantic search by meaning with an optional dense backend. Content enhancement and WordNet query expansion. Light defaults, heavy options on demand.</a:t>
-            </a:r>
-            <a:endParaRPr lang="en-US" dirty="0"/>
+              <a:t>Module B is language understanding and generation. Summarization is extractive by default, ranking sentences by TF-IDF importance, with an optional transformer summarizer behind a flag. Semantic search ranks the whole corpus by meaning rather than keywords, with an optional dense embedding backend. There is also content enhancement and WordNet query expansion. The theme is a light default that runs anywhere, with a heavier upgrade one flag away.</a:t>
+            </a:r>
           </a:p>
         </p:txBody>
       </p:sp>
@@ -1571,10 +1547,8 @@
           <a:lstStyle/>
           <a:p>
             <a:r>
-              <a:rPr lang="en-US" dirty="0"/>
-              <a:t>Module C detects the language, translates to English, then runs the same pipeline I already trust. Non-English articles get the same treatment as English ones.</a:t>
-            </a:r>
-            <a:endParaRPr lang="en-US" dirty="0"/>
+              <a:t>Module C is multilingual intelligence. It detects the language, translates the text to English, and then runs the same pipeline I already trust, so a Spanish or French article gets the same classification, sentiment, and entities as an English one. Translating into English is the honest choice with these tools rather than pretending English-trained models read every language.</a:t>
+            </a:r>
           </a:p>
         </p:txBody>
       </p:sp>
@@ -1659,10 +1633,8 @@
           <a:lstStyle/>
           <a:p>
             <a:r>
-              <a:rPr lang="en-US" dirty="0"/>
-              <a:t>Module D, the piece I am most proud of. An intent classifier reads a plain question and a query processor routes it to the right component and formats the answer. It works because the refactor gave every capability a clean interface.</a:t>
-            </a:r>
-            <a:endParaRPr lang="en-US" dirty="0"/>
+              <a:t>Module D is the conversational interface, and it is the piece I am most proud of because it ties everything together. An intent classifier reads a plain question like 'what is the sentiment' and a query processor routes it to the right module and formats the answer. It works because each capability is a clean class the router can call. The six intents are classify, sentiment, entities, summarize, search, and topics.</a:t>
+            </a:r>
           </a:p>
         </p:txBody>
       </p:sp>
@@ -1747,10 +1719,8 @@
           <a:lstStyle/>
           <a:p>
             <a:r>
-              <a:rPr lang="en-US" dirty="0"/>
-              <a:t>The bonus web app. Three panels: analyze an article, ask a question about it, and find similar coverage. It is the same module code exposed through Flask. In the recording, demo each panel live.</a:t>
-            </a:r>
-            <a:endParaRPr lang="en-US" dirty="0"/>
+              <a:t>This is the bonus web front end, and it is live online at the GitHub Pages link in the README. It has three panels: Analyze an article returns category, sentiment, entities, and a summary; Ask NewsBot answers a plain question about that article; and Find similar articles searches the corpus by meaning. It is the same module code exposed in a browser so a non-technical user can use the system.</a:t>
+            </a:r>
           </a:p>
         </p:txBody>
       </p:sp>

</xml_diff>